<commit_message>
Despliegue sin costo, guion de sustentacion y notas del expositor
- Clave KMS propia ahora opcional y desactivada por defecto (ADR-009): la
  demostracion cabe en la capa gratuita de AWS sin perder cifrado en reposo.
- La API devuelve required_headers al firmar la subida: la app deja de asumir
  como esta cifrado el bucket.
- Nuevo docs/10-guion-sustentacion.md y notas del expositor en las 14 diapositivas.
- Costos recalculados con datos verificados de la capa gratuita.
</commit_message>
<xml_diff>
--- a/presentacion/EcoRuta-presentacion.pptx
+++ b/presentacion/EcoRuta-presentacion.pptx
@@ -486,7 +486,7 @@
             <c:bubble3D val="0"/>
             <c:spPr>
               <a:solidFill>
-                <a:srgbClr val="B8CFA0"/>
+                <a:srgbClr val="7FA85C"/>
               </a:solidFill>
               <a:ln w="25400" cap="flat">
                 <a:solidFill>
@@ -503,7 +503,7 @@
             <c:bubble3D val="0"/>
             <c:spPr>
               <a:solidFill>
-                <a:srgbClr val="D4E2C4"/>
+                <a:srgbClr val="B8CFA0"/>
               </a:solidFill>
               <a:ln w="25400" cap="flat">
                 <a:solidFill>
@@ -517,6 +517,23 @@
           </c:dPt>
           <c:dPt>
             <c:idx val="5"/>
+            <c:bubble3D val="0"/>
+            <c:spPr>
+              <a:solidFill>
+                <a:srgbClr val="D4E2C4"/>
+              </a:solidFill>
+              <a:ln w="25400" cap="flat">
+                <a:solidFill>
+                  <a:srgbClr val="FFFFFF"/>
+                </a:solidFill>
+                <a:prstDash val="solid"/>
+                <a:round/>
+              </a:ln>
+              <a:effectLst/>
+            </c:spPr>
+          </c:dPt>
+          <c:dPt>
+            <c:idx val="6"/>
             <c:bubble3D val="0"/>
             <c:spPr>
               <a:solidFill>
@@ -683,6 +700,31 @@
               <c:showPercent val="0"/>
               <c:showBubbleSize val="0"/>
             </c:dLbl>
+            <c:dLbl>
+              <c:idx val="6"/>
+              <c:numFmt formatCode="General" sourceLinked="0"/>
+              <c:spPr/>
+              <c:txPr>
+                <a:bodyPr/>
+                <a:lstStyle/>
+                <a:p>
+                  <a:pPr>
+                    <a:defRPr sz="1200" b="0" i="0" u="none" strike="noStrike">
+                      <a:solidFill>
+                        <a:srgbClr val="000000"/>
+                      </a:solidFill>
+                      <a:latin typeface="Arial"/>
+                    </a:defRPr>
+                  </a:pPr>
+                </a:p>
+              </c:txPr>
+              <c:showLegendKey val="0"/>
+              <c:showVal val="0"/>
+              <c:showCatName val="0"/>
+              <c:showSerName val="0"/>
+              <c:showPercent val="0"/>
+              <c:showBubbleSize val="0"/>
+            </c:dLbl>
             <c:numFmt formatCode="General" sourceLinked="0"/>
             <c:txPr>
               <a:bodyPr/>
@@ -708,25 +750,28 @@
           </c:dLbls>
           <c:cat>
             <c:strRef>
-              <c:f>Sheet1!$A$2:$A$7</c:f>
+              <c:f>Sheet1!$A$2:$A$8</c:f>
               <c:strCache>
-                <c:ptCount val="6"/>
+                <c:ptCount val="7"/>
                 <c:pt idx="0">
                   <c:v>Rekognition</c:v>
                 </c:pt>
                 <c:pt idx="1">
+                  <c:v>KMS</c:v>
+                </c:pt>
+                <c:pt idx="2">
                   <c:v>EventBridge · SNS · CloudWatch</c:v>
                 </c:pt>
-                <c:pt idx="2">
+                <c:pt idx="3">
                   <c:v>DynamoDB</c:v>
                 </c:pt>
-                <c:pt idx="3">
+                <c:pt idx="4">
                   <c:v>S3</c:v>
                 </c:pt>
-                <c:pt idx="4">
+                <c:pt idx="5">
                   <c:v>Lambda</c:v>
                 </c:pt>
-                <c:pt idx="5">
+                <c:pt idx="6">
                   <c:v>API Gateway</c:v>
                 </c:pt>
               </c:strCache>
@@ -734,25 +779,28 @@
           </c:cat>
           <c:val>
             <c:numRef>
-              <c:f>Sheet1!$B$2:$B$7</c:f>
+              <c:f>Sheet1!$B$2:$B$8</c:f>
               <c:numCache>
-                <c:ptCount val="6"/>
+                <c:ptCount val="7"/>
                 <c:pt idx="0">
                   <c:v>3</c:v>
                 </c:pt>
                 <c:pt idx="1">
+                  <c:v>1</c:v>
+                </c:pt>
+                <c:pt idx="2">
                   <c:v>0.6</c:v>
                 </c:pt>
-                <c:pt idx="2">
+                <c:pt idx="3">
                   <c:v>0.1</c:v>
-                </c:pt>
-                <c:pt idx="3">
-                  <c:v>0.05</c:v>
                 </c:pt>
                 <c:pt idx="4">
                   <c:v>0.05</c:v>
                 </c:pt>
                 <c:pt idx="5">
+                  <c:v>0.05</c:v>
+                </c:pt>
+                <c:pt idx="6">
                   <c:v>0.04</c:v>
                 </c:pt>
               </c:numCache>
@@ -1289,7 +1337,7 @@
           <a:p>
             <a:r>
               <a:rPr lang="en-US" dirty="0"/>
-              <a:t>Una prueba encontró un defecto real: create devolvía el ítem completo de DynamoDB, incluyendo user_id y ttl. Se corrigió centralizando la proyección pública.</a:t>
+              <a:t>CALIDAD (60 s). Los cuatro numeros y una historia concreta que vale mas que todos ellos: una prueba fallo la primera vez que la corri porque la API devolvia el identificador del usuario junto con el reporte. Es una fuga de datos personales que no se ve leyendo el codigo, solo se ve cuando alguien la prueba.</a:t>
             </a:r>
             <a:endParaRPr lang="en-US" dirty="0"/>
           </a:p>
@@ -1377,7 +1425,7 @@
           <a:p>
             <a:r>
               <a:rPr lang="en-US" dirty="0"/>
-              <a:t/>
+              <a:t>COSTOS (60 s, recortable). 'La demostracion cabe en la capa gratuita; la operacion real de una localidad cuesta menos de cinco dolares al mes. Pero el dato interesante es la composicion: el 62 % es el servicio de vision por computador.' Ese puente hacia la investigacion es el mejor momento de la presentacion: uselo para pasar a la siguiente diapositiva.</a:t>
             </a:r>
             <a:endParaRPr lang="en-US" dirty="0"/>
           </a:p>
@@ -1465,7 +1513,7 @@
           <a:p>
             <a:r>
               <a:rPr lang="en-US" dirty="0"/>
-              <a:t/>
+              <a:t>SEMILLERO (2 min). Si le interesa la convocatoria, esta es la diapositiva por la que vino. Nombre el vacio: hay literatura sobre reporte ciudadano y sobre clasificacion de residuos, poca sobre las dos juntas en ciudades latinoamericanas. Explique la Fase 1 con concrecion: comparar contra el inventario oficial publicado como dato abierto y medir precision y exhaustividad. Es un experimento ejecutable, no una intencion.</a:t>
             </a:r>
             <a:endParaRPr lang="en-US" dirty="0"/>
           </a:p>
@@ -1553,7 +1601,7 @@
           <a:p>
             <a:r>
               <a:rPr lang="en-US" dirty="0"/>
-              <a:t/>
+              <a:t>ENTREGABLES (30 s). Muestre el repositorio en vivo, no la diapositiva: baje por el README, abra un ADR, abra la carpeta de evidencias. Diez segundos de repositorio real valen mas que un minuto describiendolo.</a:t>
             </a:r>
             <a:endParaRPr lang="en-US" dirty="0"/>
           </a:p>
@@ -1729,7 +1777,7 @@
           <a:p>
             <a:r>
               <a:rPr lang="en-US" dirty="0"/>
-              <a:t>El ciclo entre que el residuo aparece y la cuadrilla llega es largo, y los costos son evitables.</a:t>
+              <a:t>PROBLEMA (90 s). Empiece con un caso concreto: 'todos conocemos una esquina del barrio donde aparece basura; la recogen y a la semana vuelve media cuadra mas alla'. Luego los tres rasgos sin leerlos: es dinamico (el inventario queda obsoleto en semanas), es local (lo detecta el vecino, no el operador de la macro-ruta), la informacion no fluye (texto libre sin coordenadas obliga a verificar en campo). Cierre con la consecuencia operativa.</a:t>
             </a:r>
             <a:endParaRPr lang="en-US" dirty="0"/>
           </a:p>
@@ -1817,7 +1865,7 @@
           <a:p>
             <a:r>
               <a:rPr lang="en-US" dirty="0"/>
-              <a:t/>
+              <a:t>DELIMITACION (60 s). Lea la pregunta de investigacion completa y en voz alta: es lo que convierte el trabajo en algo evaluable y es lo que el jurado de semillero espera oir. De los cinco objetivos mencione solo el 1 y el 2; el resto esta en pantalla.</a:t>
             </a:r>
             <a:endParaRPr lang="en-US" dirty="0"/>
           </a:p>
@@ -1905,7 +1953,7 @@
           <a:p>
             <a:r>
               <a:rPr lang="en-US" dirty="0"/>
-              <a:t/>
+              <a:t>SOLUCION (60 s). Recorra los cinco pasos, una frase cada uno. AQUI VA LA DEMOSTRACION EN VIVO: tome una foto con el celular, envie el reporte, muestre el mapa. Remate: 'lo que acaban de ver son treinta segundos; si reportar cuesta mas que ignorar el problema, nadie reporta'.</a:t>
             </a:r>
             <a:endParaRPr lang="en-US" dirty="0"/>
           </a:p>
@@ -1993,7 +2041,7 @@
           <a:p>
             <a:r>
               <a:rPr lang="en-US" dirty="0"/>
-              <a:t>La foto no atraviesa la capa de cómputo: la app pide una URL prefirmada y sube directo a S3. Eso evita el límite de 6 MB de Lambda y reduce latencia y costo.</a:t>
+              <a:t>ARQUITECTURA (2 min). La diapositiva mas importante para la nota. No enumere servicios: explique decisiones. Borde: la validacion del token la hace API Gateway, no mi codigo. Computo: ocho funciones para tener minimo privilegio real. Datos: una sola tabla y ninguna operacion usa Scan. La flecha gruesa: la foto no atraviesa el computo, la app sube directo a S3 con URL prefirmada, lo que evita el limite de 6 MB de Lambda.</a:t>
             </a:r>
             <a:endParaRPr lang="en-US" dirty="0"/>
           </a:p>
@@ -2081,7 +2129,7 @@
           <a:p>
             <a:r>
               <a:rPr lang="en-US" dirty="0"/>
-              <a:t/>
+              <a:t>JUSTIFICACION (90 s, recortable). No lea las seis filas: elija dos y explíquelas bien. Luego mencione lo descartado, que es lo que demuestra criterio: 'consideré PostgreSQL con PostGIS; lo descarté porque mis consultas son de proximidad, que el geohash resuelve a costo constante, y PostGIS obligaba a una instancia siempre encendida en una VPC que costaria mas que toda la solucion'.</a:t>
             </a:r>
             <a:endParaRPr lang="en-US" dirty="0"/>
           </a:p>
@@ -2169,7 +2217,7 @@
           <a:p>
             <a:r>
               <a:rPr lang="en-US" dirty="0"/>
-              <a:t/>
+              <a:t>MODELO DE DATOS (90 s, recortable). Frase clave: 'en DynamoDB uno no disena desde las entidades sino desde las consultas; tengo exactamente cuatro y cada una tiene su clave'. Si hay tiempo explique el geohash a dos precisiones (se guarda con 7, se particiona por 6) para que las particiones no sean ni diminutas ni calientes.</a:t>
             </a:r>
             <a:endParaRPr lang="en-US" dirty="0"/>
           </a:p>
@@ -2257,7 +2305,7 @@
           <a:p>
             <a:r>
               <a:rPr lang="en-US" dirty="0"/>
-              <a:t/>
+              <a:t>ALGORITMO (2 min). Aqui se gana el criterio de rigor tecnico: es lo unico verdaderamente propio del proyecto. Explique los cuatro pasos y sea explicito con el umbral: 'un grupo solo es punto critico con tres o mas reportes; sin ese umbral una queja aislada movilizaria una cuadrilla'. Senale el panel derecho: no son casos ilustrativos, son pruebas que corren en cada push.</a:t>
             </a:r>
             <a:endParaRPr lang="en-US" dirty="0"/>
           </a:p>
@@ -2345,7 +2393,7 @@
           <a:p>
             <a:r>
               <a:rPr lang="en-US" dirty="0"/>
-              <a:t/>
+              <a:t>SEGURIDAD (90 s). Elija dos tarjetas, no las seis: minimo privilegio real y seudonimizacion en logs. Luego LEA LA DEUDA RECONOCIDA: 'no verifico que la foto se tomo donde dice, no hay WAF y no desenfoco rostros; lo documente porque un analisis de seguridad que solo lista lo que si hice no es un analisis de seguridad'. Si no lo dice usted, se lo preguntan igual.</a:t>
             </a:r>
             <a:endParaRPr lang="en-US" dirty="0"/>
           </a:p>
@@ -3228,7 +3276,7 @@
                 <a:ea typeface="Cambria" pitchFamily="34" charset="-122"/>
                 <a:cs typeface="Cambria" pitchFamily="34" charset="-120"/>
               </a:rPr>
-              <a:t>109</a:t>
+              <a:t>112</a:t>
             </a:r>
             <a:endParaRPr lang="en-US" sz="4000" dirty="0"/>
           </a:p>
@@ -3372,7 +3420,7 @@
                 <a:ea typeface="Cambria" pitchFamily="34" charset="-122"/>
                 <a:cs typeface="Cambria" pitchFamily="34" charset="-120"/>
               </a:rPr>
-              <a:t>80 %</a:t>
+              <a:t>82 %</a:t>
             </a:r>
             <a:endParaRPr lang="en-US" sz="4000" dirty="0"/>
           </a:p>
@@ -4266,7 +4314,7 @@
                 <a:ea typeface="Cambria" pitchFamily="34" charset="-122"/>
                 <a:cs typeface="Cambria" pitchFamily="34" charset="-120"/>
               </a:rPr>
-              <a:t>Menos de 4 dólares al mes en el piloto</a:t>
+              <a:t>Demostrarla no cuesta nada; operarla, cinco dólares</a:t>
             </a:r>
             <a:endParaRPr lang="en-US" sz="3400" dirty="0"/>
           </a:p>
@@ -4305,7 +4353,7 @@
                 <a:ea typeface="Calibri" pitchFamily="34" charset="-122"/>
                 <a:cs typeface="Calibri" pitchFamily="34" charset="-120"/>
               </a:rPr>
-              <a:t>Escenario: una localidad, 3.000 reportes y 30.000 consultas de mapa al mes, con foto promedio de 400 KB.</a:t>
+              <a:t>Operación real de una localidad: 3.000 reportes y 30.000 consultas de mapa al mes, con foto promedio de 400 KB.</a:t>
             </a:r>
             <a:endParaRPr lang="en-US" sz="1350" dirty="0"/>
           </a:p>
@@ -4336,11 +4384,11 @@
         <p:spPr>
           <a:xfrm>
             <a:off x="6583680" y="1828800"/>
-            <a:ext cx="4937760" cy="1371600"/>
+            <a:ext cx="4937760" cy="1417320"/>
           </a:xfrm>
           <a:prstGeom prst="roundRect">
             <a:avLst>
-              <a:gd name="adj" fmla="val 6667"/>
+              <a:gd name="adj" fmla="val 6452"/>
             </a:avLst>
           </a:prstGeom>
           <a:solidFill>
@@ -4362,24 +4410,24 @@
         </p:nvSpPr>
         <p:spPr>
           <a:xfrm>
-            <a:off x="6903720" y="2057400"/>
-            <a:ext cx="4754880" cy="548640"/>
-          </a:xfrm>
-          <a:prstGeom prst="rect">
-            <a:avLst/>
-          </a:prstGeom>
-          <a:noFill/>
-          <a:ln/>
-        </p:spPr>
-        <p:txBody>
-          <a:bodyPr wrap="square" lIns="0" tIns="0" rIns="0" bIns="0" rtlCol="0" anchor="ctr"/>
-          <a:lstStyle/>
-          <a:p>
-            <a:pPr indent="0" marL="0">
-              <a:buNone/>
-            </a:pPr>
-            <a:r>
-              <a:rPr lang="en-US" sz="3200" b="1" dirty="0">
+            <a:off x="6903720" y="2029968"/>
+            <a:ext cx="4754880" cy="502920"/>
+          </a:xfrm>
+          <a:prstGeom prst="rect">
+            <a:avLst/>
+          </a:prstGeom>
+          <a:noFill/>
+          <a:ln/>
+        </p:spPr>
+        <p:txBody>
+          <a:bodyPr wrap="square" lIns="0" tIns="0" rIns="0" bIns="0" rtlCol="0" anchor="ctr"/>
+          <a:lstStyle/>
+          <a:p>
+            <a:pPr indent="0" marL="0">
+              <a:buNone/>
+            </a:pPr>
+            <a:r>
+              <a:rPr lang="en-US" sz="3400" b="1" dirty="0">
                 <a:solidFill>
                   <a:srgbClr val="FFFFFF"/>
                 </a:solidFill>
@@ -4387,9 +4435,9 @@
                 <a:ea typeface="Cambria" pitchFamily="34" charset="-122"/>
                 <a:cs typeface="Cambria" pitchFamily="34" charset="-120"/>
               </a:rPr>
-              <a:t>≈ 3,85 USD / mes</a:t>
-            </a:r>
-            <a:endParaRPr lang="en-US" sz="3200" dirty="0"/>
+              <a:t>0 USD</a:t>
+            </a:r>
+            <a:endParaRPr lang="en-US" sz="3400" dirty="0"/>
           </a:p>
         </p:txBody>
       </p:sp>
@@ -4401,7 +4449,7 @@
         </p:nvSpPr>
         <p:spPr>
           <a:xfrm>
-            <a:off x="6903720" y="2633472"/>
+            <a:off x="6903720" y="2578608"/>
             <a:ext cx="4754880" cy="274320"/>
           </a:xfrm>
           <a:prstGeom prst="rect">
@@ -4426,7 +4474,7 @@
                 <a:ea typeface="Calibri" pitchFamily="34" charset="-122"/>
                 <a:cs typeface="Calibri" pitchFamily="34" charset="-120"/>
               </a:rPr>
-              <a:t>Costo total estimado del piloto completo</a:t>
+              <a:t>La demostración cabe en la capa gratuita de AWS</a:t>
             </a:r>
             <a:endParaRPr lang="en-US" sz="1200" dirty="0"/>
           </a:p>
@@ -4440,7 +4488,46 @@
         </p:nvSpPr>
         <p:spPr>
           <a:xfrm>
-            <a:off x="6583680" y="3429000"/>
+            <a:off x="6903720" y="2834640"/>
+            <a:ext cx="4754880" cy="274320"/>
+          </a:xfrm>
+          <a:prstGeom prst="rect">
+            <a:avLst/>
+          </a:prstGeom>
+          <a:noFill/>
+          <a:ln/>
+        </p:spPr>
+        <p:txBody>
+          <a:bodyPr wrap="square" lIns="0" tIns="0" rIns="0" bIns="0" rtlCol="0" anchor="ctr"/>
+          <a:lstStyle/>
+          <a:p>
+            <a:pPr indent="0" marL="0">
+              <a:buNone/>
+            </a:pPr>
+            <a:r>
+              <a:rPr lang="en-US" sz="1150" dirty="0">
+                <a:solidFill>
+                  <a:srgbClr val="F5F5F0"/>
+                </a:solidFill>
+                <a:latin typeface="Calibri" pitchFamily="34" charset="0"/>
+                <a:ea typeface="Calibri" pitchFamily="34" charset="-122"/>
+                <a:cs typeface="Calibri" pitchFamily="34" charset="-120"/>
+              </a:rPr>
+              <a:t>Operación real de una localidad: ≈ 4,85 USD / mes</a:t>
+            </a:r>
+            <a:endParaRPr lang="en-US" sz="1150" dirty="0"/>
+          </a:p>
+        </p:txBody>
+      </p:sp>
+      <p:sp>
+        <p:nvSpPr>
+          <p:cNvPr id="10" name="Text 7"/>
+          <p:cNvSpPr txBox="1"/>
+          <p:nvPr/>
+        </p:nvSpPr>
+        <p:spPr>
+          <a:xfrm>
+            <a:off x="6583680" y="3520440"/>
             <a:ext cx="4937760" cy="256032"/>
           </a:xfrm>
           <a:prstGeom prst="rect">
@@ -4465,7 +4552,7 @@
                 <a:ea typeface="Cambria" pitchFamily="34" charset="-122"/>
                 <a:cs typeface="Cambria" pitchFamily="34" charset="-120"/>
               </a:rPr>
-              <a:t>El 78 % del costo es Rekognition</a:t>
+              <a:t>El 62 % del costo es Rekognition</a:t>
             </a:r>
             <a:endParaRPr lang="en-US" sz="1400" dirty="0"/>
           </a:p>
@@ -4473,13 +4560,13 @@
       </p:sp>
       <p:sp>
         <p:nvSpPr>
-          <p:cNvPr id="10" name="Text 7"/>
-          <p:cNvSpPr txBox="1"/>
-          <p:nvPr/>
-        </p:nvSpPr>
-        <p:spPr>
-          <a:xfrm>
-            <a:off x="6583680" y="3685032"/>
+          <p:cNvPr id="11" name="Text 8"/>
+          <p:cNvSpPr txBox="1"/>
+          <p:nvPr/>
+        </p:nvSpPr>
+        <p:spPr>
+          <a:xfrm>
+            <a:off x="6583680" y="3776472"/>
             <a:ext cx="4937760" cy="457200"/>
           </a:xfrm>
           <a:prstGeom prst="rect">
@@ -4507,7 +4594,7 @@
                 <a:ea typeface="Calibri" pitchFamily="34" charset="-122"/>
                 <a:cs typeface="Calibri" pitchFamily="34" charset="-120"/>
               </a:rPr>
-              <a:t>Un clasificador propio ejecutado en el dispositivo eliminaría casi todo el gasto variable.</a:t>
+              <a:t>Un clasificador propio en el dispositivo eliminaría ese renglón: es el argumento económico de la investigación.</a:t>
             </a:r>
             <a:endParaRPr lang="en-US" sz="1150" dirty="0"/>
           </a:p>
@@ -4515,13 +4602,13 @@
       </p:sp>
       <p:sp>
         <p:nvSpPr>
-          <p:cNvPr id="11" name="Text 8"/>
-          <p:cNvSpPr txBox="1"/>
-          <p:nvPr/>
-        </p:nvSpPr>
-        <p:spPr>
-          <a:xfrm>
-            <a:off x="6583680" y="4206240"/>
+          <p:cNvPr id="12" name="Text 9"/>
+          <p:cNvSpPr txBox="1"/>
+          <p:nvPr/>
+        </p:nvSpPr>
+        <p:spPr>
+          <a:xfrm>
+            <a:off x="6583680" y="4297680"/>
             <a:ext cx="4937760" cy="256032"/>
           </a:xfrm>
           <a:prstGeom prst="rect">
@@ -4554,13 +4641,13 @@
       </p:sp>
       <p:sp>
         <p:nvSpPr>
-          <p:cNvPr id="12" name="Text 9"/>
-          <p:cNvSpPr txBox="1"/>
-          <p:nvPr/>
-        </p:nvSpPr>
-        <p:spPr>
-          <a:xfrm>
-            <a:off x="6583680" y="4462272"/>
+          <p:cNvPr id="13" name="Text 10"/>
+          <p:cNvSpPr txBox="1"/>
+          <p:nvPr/>
+        </p:nvSpPr>
+        <p:spPr>
+          <a:xfrm>
+            <a:off x="6583680" y="4553712"/>
             <a:ext cx="4937760" cy="457200"/>
           </a:xfrm>
           <a:prstGeom prst="rect">
@@ -4596,13 +4683,13 @@
       </p:sp>
       <p:sp>
         <p:nvSpPr>
-          <p:cNvPr id="13" name="Text 10"/>
-          <p:cNvSpPr txBox="1"/>
-          <p:nvPr/>
-        </p:nvSpPr>
-        <p:spPr>
-          <a:xfrm>
-            <a:off x="6583680" y="4983480"/>
+          <p:cNvPr id="14" name="Text 11"/>
+          <p:cNvSpPr txBox="1"/>
+          <p:nvPr/>
+        </p:nvSpPr>
+        <p:spPr>
+          <a:xfrm>
+            <a:off x="6583680" y="5074920"/>
             <a:ext cx="4937760" cy="256032"/>
           </a:xfrm>
           <a:prstGeom prst="rect">
@@ -4627,7 +4714,7 @@
                 <a:ea typeface="Cambria" pitchFamily="34" charset="-122"/>
                 <a:cs typeface="Cambria" pitchFamily="34" charset="-120"/>
               </a:rPr>
-              <a:t>Decisiones que abaratan</a:t>
+              <a:t>La clave KMS es opcional</a:t>
             </a:r>
             <a:endParaRPr lang="en-US" sz="1400" dirty="0"/>
           </a:p>
@@ -4635,13 +4722,13 @@
       </p:sp>
       <p:sp>
         <p:nvSpPr>
-          <p:cNvPr id="14" name="Text 11"/>
-          <p:cNvSpPr txBox="1"/>
-          <p:nvPr/>
-        </p:nvSpPr>
-        <p:spPr>
-          <a:xfrm>
-            <a:off x="6583680" y="5239512"/>
+          <p:cNvPr id="15" name="Text 12"/>
+          <p:cNvSpPr txBox="1"/>
+          <p:nvPr/>
+        </p:nvSpPr>
+        <p:spPr>
+          <a:xfrm>
+            <a:off x="6583680" y="5330952"/>
             <a:ext cx="4937760" cy="457200"/>
           </a:xfrm>
           <a:prstGeom prst="rect">
@@ -4669,7 +4756,7 @@
                 <a:ea typeface="Calibri" pitchFamily="34" charset="-122"/>
                 <a:cs typeface="Calibri" pitchFamily="34" charset="-120"/>
               </a:rPr>
-              <a:t>arm64 (~20 % menos por invocación), bucket key de KMS y ciclo de vida hacia clases frías en S3.</a:t>
+              <a:t>Único cargo fijo del diseño (1 USD/mes). Desactivada por defecto; el dato sigue cifrado con claves de AWS.</a:t>
             </a:r>
             <a:endParaRPr lang="en-US" sz="1150" dirty="0"/>
           </a:p>
@@ -4677,7 +4764,7 @@
       </p:sp>
       <p:sp>
         <p:nvSpPr>
-          <p:cNvPr id="15" name="Text 12"/>
+          <p:cNvPr id="16" name="Text 13"/>
           <p:cNvSpPr txBox="1"/>
           <p:nvPr/>
         </p:nvSpPr>
@@ -4716,7 +4803,7 @@
       </p:sp>
       <p:sp>
         <p:nvSpPr>
-          <p:cNvPr id="16" name="Text 13"/>
+          <p:cNvPr id="17" name="Text 14"/>
           <p:cNvSpPr txBox="1"/>
           <p:nvPr/>
         </p:nvSpPr>
@@ -6291,7 +6378,7 @@
                 <a:ea typeface="Calibri" pitchFamily="34" charset="-122"/>
                 <a:cs typeface="Calibri" pitchFamily="34" charset="-120"/>
               </a:rPr>
-              <a:t>Ocho handlers, capa de dominio y servicios, repositorios intercambiables, 109 pruebas y peticiones listas en api.http.</a:t>
+              <a:t>Ocho handlers, capa de dominio y servicios, repositorios intercambiables, 112 pruebas y peticiones listas en api.http.</a:t>
             </a:r>
             <a:endParaRPr lang="en-US" sz="1100" dirty="0"/>
           </a:p>
@@ -6591,7 +6678,7 @@
                 <a:ea typeface="Calibri" pitchFamily="34" charset="-122"/>
                 <a:cs typeface="Calibri" pitchFamily="34" charset="-120"/>
               </a:rPr>
-              <a:t>Nueve documentos: análisis, arquitectura, modelo de datos, seguridad, ADR, pruebas, proyección, despliegue y referencia de API.</a:t>
+              <a:t>Diez documentos: análisis, arquitectura, modelo de datos, seguridad, ADR, pruebas, proyección, despliegue, API y guion de sustentación.</a:t>
             </a:r>
             <a:endParaRPr lang="en-US" sz="1100" dirty="0"/>
           </a:p>
@@ -7218,7 +7305,7 @@
                 <a:ea typeface="Calibri" pitchFamily="34" charset="-122"/>
                 <a:cs typeface="Calibri" pitchFamily="34" charset="-120"/>
               </a:rPr>
-              <a:t>109 pruebas, roles de mínimo privilegio, infraestructura como código y CI</a:t>
+              <a:t>112 pruebas, roles de mínimo privilegio, infraestructura como código y CI</a:t>
             </a:r>
             <a:endParaRPr lang="en-US" sz="1200" dirty="0"/>
           </a:p>

</xml_diff>

<commit_message>
Miniatura con los retratos del equipo y datos de los dos integrantes
- Miniatura 16:9 con los retratos de Diego Gamba y Mariana Diez, titulo, temas y
  herramientas, lista para cargar en YouTube.
- Mariana Diez incorporada en la guia del taller, el guion del video, la portada de
  la presentacion y la licencia.
- Corregido el nombre de la facultad: Ingenieria y Ciencias Ambientales.

Co-Authored-By: Claude Opus 5 <noreply@anthropic.com>
Claude-Session: https://claude.ai/code/session_015yfA9dxhZC2GKwvkktPgNS
</commit_message>
<xml_diff>
--- a/presentacion/EcoRuta-presentacion.pptx
+++ b/presentacion/EcoRuta-presentacion.pptx
@@ -3061,7 +3061,7 @@
                 <a:ea typeface="Calibri" pitchFamily="34" charset="-122"/>
                 <a:cs typeface="Calibri" pitchFamily="34" charset="-120"/>
               </a:rPr>
-              <a:t>Diego Gamba</a:t>
+              <a:t>Diego Gamba  ·  Mariana Diez</a:t>
             </a:r>
             <a:endParaRPr lang="en-US" sz="1500" dirty="0"/>
           </a:p>
@@ -3100,7 +3100,7 @@
                 <a:ea typeface="Calibri" pitchFamily="34" charset="-122"/>
                 <a:cs typeface="Calibri" pitchFamily="34" charset="-120"/>
               </a:rPr>
-              <a:t>Diseño de Aplicaciones Móviles · Facultad de Ingeniería, Ciencias y Administración</a:t>
+              <a:t>Diseño de Aplicaciones Móviles · Facultad de Ingeniería y Ciencias Ambientales</a:t>
             </a:r>
             <a:endParaRPr lang="en-US" sz="1100" dirty="0"/>
           </a:p>
@@ -7425,7 +7425,7 @@
                 <a:ea typeface="Calibri" pitchFamily="34" charset="-122"/>
                 <a:cs typeface="Calibri" pitchFamily="34" charset="-120"/>
               </a:rPr>
-              <a:t>Diego Gamba  ·  github.com/DiegoGamba/ecoruta</a:t>
+              <a:t>Diego Gamba · Mariana Diez  ·  github.com/DiegoGamba/ecoruta</a:t>
             </a:r>
             <a:endParaRPr lang="en-US" sz="1200" dirty="0"/>
           </a:p>

</xml_diff>